<commit_message>
Lectures: slop sweep; guide: expanded common-pitfalls section (user edit)
Lecture sweep (marp sources + build_pptx.py, decks rebuilt): tightened the
repeated "X. It will not Y." constructions ("give you a start, not the
answer"; "narrow the problem without solving it"), replaced the pull-quote
endings on the design-tension and idealized-beam slides, gave the
assumptions slide a concrete consequence ("each gap widens the error bar on
the LTB capacity"), and cut throat-clearing on the responsibility slide.

Guide: the pitfalls list becomes two named habits — trusting precision
without assumptions, and stopping at the first recipe that runs — each with
the specific fingerprints graders should look for.

Co-Authored-By: Claude Fable 5 <noreply@anthropic.com>
</commit_message>
<xml_diff>
--- a/me323/Module1_drafts/ME323_Module1_Lecture1.pptx
+++ b/me323/Module1_drafts/ME323_Module1_Lecture1.pptx
@@ -3277,7 +3277,7 @@
                 <a:latin typeface="Calibri"/>
               </a:rPr>
               <a:t>Pick a 3D-printed I-beam that carries the most load per gram.
-The equations give you a start. They will not give you the answer.</a:t>
+The equations give you a start, not the answer.</a:t>
             </a:r>
           </a:p>
         </p:txBody>
@@ -4940,7 +4940,7 @@
                 </a:solidFill>
                 <a:latin typeface="Calibri"/>
               </a:rPr>
-              <a:t>The formula is exact only for an idealized beam. Ours is not quite that beam.</a:t>
+              <a:t>The formula is exact for an idealized beam, and ours differs from it in four ways.</a:t>
             </a:r>
           </a:p>
           <a:p>
@@ -5020,7 +5020,7 @@
                 </a:solidFill>
                 <a:latin typeface="Calibri"/>
               </a:rPr>
-              <a:t>Each gap is a reason the equation narrows the answer without settling it.</a:t>
+              <a:t>Each gap widens the error bar you should carry on the LTB capacity.</a:t>
             </a:r>
           </a:p>
         </p:txBody>
@@ -5404,7 +5404,7 @@
                 </a:solidFill>
                 <a:latin typeface="Calibri"/>
               </a:rPr>
-              <a:t>You just saw Iy, J, Cw, warping, load height, and effective length. Here is exactly what you are responsible for:</a:t>
+              <a:t>You just saw Iy, J, Cw, warping, load height, and effective length. You are responsible for this much of it:</a:t>
             </a:r>
           </a:p>
           <a:p>
@@ -5468,7 +5468,7 @@
                 </a:solidFill>
                 <a:latin typeface="Calibri"/>
               </a:rPr>
-              <a:t>The test of understanding is not the derivation. It is: what happens to the LTB branch if the fixture braces the compression flange, and would you still trust the equation optimum?</a:t>
+              <a:t>The test of understanding: what happens to the LTB branch if the fixture braces the compression flange, and would you still trust the equation optimum?</a:t>
             </a:r>
           </a:p>
         </p:txBody>
@@ -7209,7 +7209,7 @@
                 </a:solidFill>
                 <a:latin typeface="Calibri"/>
               </a:rPr>
-              <a:t>We will price the layer-line mode with one calibrated number — but that number drifts with print session and support condition, and the other two problems remain. The equations narrow the problem. They do not solve it.</a:t>
+              <a:t>We will price the layer-line mode with one calibrated number — but that number drifts with print session and support condition, and the other two problems remain. The equations narrow the problem without solving it.</a:t>
             </a:r>
           </a:p>
         </p:txBody>
@@ -8205,7 +8205,7 @@
                 </a:solidFill>
                 <a:latin typeface="Calibri"/>
               </a:rPr>
-              <a:t>The efficient shape and the failure modes pull against each other. That tension is the design problem.</a:t>
+              <a:t>The efficient shape and the failure modes pull against each other; resolving that tension is the design problem.</a:t>
             </a:r>
           </a:p>
         </p:txBody>

</xml_diff>